<commit_message>
style: alinha apresentacao Funcional.pptx rigorosamente a paleta oficial Locar (cinza, amarelo e branco)
</commit_message>
<xml_diff>
--- a/Funcional.pptx
+++ b/Funcional.pptx
@@ -3113,7 +3113,7 @@
             <a:avLst/>
           </a:prstGeom>
           <a:solidFill>
-            <a:srgbClr val="14171D"/>
+            <a:srgbClr val="383535"/>
           </a:solidFill>
           <a:ln>
             <a:noFill/>
@@ -3150,13 +3150,13 @@
         <p:spPr>
           <a:xfrm>
             <a:off x="0" y="0"/>
-            <a:ext cx="12191695" cy="82296"/>
+            <a:ext cx="12191695" cy="91440"/>
           </a:xfrm>
           <a:prstGeom prst="rect">
             <a:avLst/>
           </a:prstGeom>
           <a:solidFill>
-            <a:srgbClr val="F59E0B"/>
+            <a:srgbClr val="FFF212"/>
           </a:solidFill>
           <a:ln>
             <a:noFill/>
@@ -3199,7 +3199,7 @@
             <a:avLst/>
           </a:prstGeom>
           <a:solidFill>
-            <a:srgbClr val="F59E0B"/>
+            <a:srgbClr val="FFF212"/>
           </a:solidFill>
           <a:ln>
             <a:noFill/>
@@ -3276,7 +3276,7 @@
             <a:pPr>
               <a:defRPr sz="1100" b="1">
                 <a:solidFill>
-                  <a:srgbClr val="F59E0B"/>
+                  <a:srgbClr val="FFF212"/>
                 </a:solidFill>
                 <a:latin typeface="Arial"/>
               </a:defRPr>
@@ -3308,7 +3308,7 @@
               </a:spcBef>
               <a:defRPr sz="1350">
                 <a:solidFill>
-                  <a:srgbClr val="E2E8F0"/>
+                  <a:srgbClr val="F1F5F9"/>
                 </a:solidFill>
                 <a:latin typeface="Arial"/>
               </a:defRPr>
@@ -3338,11 +3338,11 @@
             <a:avLst/>
           </a:prstGeom>
           <a:solidFill>
-            <a:srgbClr val="262C38"/>
+            <a:srgbClr val="474444"/>
           </a:solidFill>
           <a:ln w="15240">
             <a:solidFill>
-              <a:srgbClr val="F59E0B"/>
+              <a:srgbClr val="FFF212"/>
             </a:solidFill>
           </a:ln>
         </p:spPr>
@@ -3393,7 +3393,7 @@
             <a:pPr>
               <a:defRPr sz="1000" b="1">
                 <a:solidFill>
-                  <a:srgbClr val="F59E0B"/>
+                  <a:srgbClr val="FFF212"/>
                 </a:solidFill>
               </a:defRPr>
             </a:pPr>
@@ -3423,7 +3423,7 @@
               </a:spcBef>
               <a:defRPr sz="950">
                 <a:solidFill>
-                  <a:srgbClr val="94A3B8"/>
+                  <a:srgbClr val="CBD5E1"/>
                 </a:solidFill>
               </a:defRPr>
             </a:pPr>
@@ -3448,11 +3448,11 @@
             <a:avLst/>
           </a:prstGeom>
           <a:solidFill>
-            <a:srgbClr val="1E232C"/>
+            <a:srgbClr val="2E2B2B"/>
           </a:solidFill>
           <a:ln w="15240">
             <a:solidFill>
-              <a:srgbClr val="3C4858"/>
+              <a:srgbClr val="5C5656"/>
             </a:solidFill>
           </a:ln>
         </p:spPr>
@@ -3518,12 +3518,12 @@
               </a:spcBef>
               <a:defRPr sz="1000">
                 <a:solidFill>
-                  <a:srgbClr val="94A3B8"/>
+                  <a:srgbClr val="CBD5E1"/>
                 </a:solidFill>
               </a:defRPr>
             </a:pPr>
             <a:r>
-              <a:t>Desenvolvido por Maikon Pinho  •  Identidade Visual: Cinza Escuro, Amarelo e Branco  •  Versão 2026</a:t>
+              <a:t>Desenvolvido por Maikon Pinho  •  Identidade Visual: Cinza Oficial (#474444), Amarelo (#FFF212) e Branco  •  2026</a:t>
             </a:r>
           </a:p>
         </p:txBody>
@@ -3561,7 +3561,7 @@
             <a:avLst/>
           </a:prstGeom>
           <a:solidFill>
-            <a:srgbClr val="14171D"/>
+            <a:srgbClr val="383535"/>
           </a:solidFill>
           <a:ln>
             <a:noFill/>
@@ -3598,13 +3598,13 @@
         <p:spPr>
           <a:xfrm>
             <a:off x="0" y="0"/>
-            <a:ext cx="12191695" cy="82296"/>
+            <a:ext cx="12191695" cy="91440"/>
           </a:xfrm>
           <a:prstGeom prst="rect">
             <a:avLst/>
           </a:prstGeom>
           <a:solidFill>
-            <a:srgbClr val="F59E0B"/>
+            <a:srgbClr val="FFF212"/>
           </a:solidFill>
           <a:ln>
             <a:noFill/>
@@ -3657,7 +3657,7 @@
             <a:pPr>
               <a:defRPr sz="950" b="1">
                 <a:solidFill>
-                  <a:srgbClr val="F59E0B"/>
+                  <a:srgbClr val="FFF212"/>
                 </a:solidFill>
                 <a:latin typeface="Arial"/>
               </a:defRPr>
@@ -3723,11 +3723,11 @@
             <a:avLst/>
           </a:prstGeom>
           <a:solidFill>
-            <a:srgbClr val="1E232C"/>
+            <a:srgbClr val="474444"/>
           </a:solidFill>
           <a:ln w="15240">
             <a:solidFill>
-              <a:srgbClr val="3C4858"/>
+              <a:srgbClr val="FFF212"/>
             </a:solidFill>
           </a:ln>
         </p:spPr>
@@ -3768,7 +3768,7 @@
             <a:avLst/>
           </a:prstGeom>
           <a:solidFill>
-            <a:srgbClr val="F59E0B"/>
+            <a:srgbClr val="FFF212"/>
           </a:solidFill>
           <a:ln>
             <a:noFill/>
@@ -3821,7 +3821,7 @@
             <a:pPr>
               <a:defRPr sz="1600" b="1">
                 <a:solidFill>
-                  <a:srgbClr val="F59E0B"/>
+                  <a:srgbClr val="FFF212"/>
                 </a:solidFill>
               </a:defRPr>
             </a:pPr>
@@ -3851,7 +3851,7 @@
               </a:spcBef>
               <a:defRPr sz="1000">
                 <a:solidFill>
-                  <a:srgbClr val="F59E0B"/>
+                  <a:srgbClr val="F1F5F9"/>
                 </a:solidFill>
               </a:defRPr>
             </a:pPr>
@@ -3870,7 +3870,7 @@
               </a:spcBef>
               <a:defRPr sz="1050">
                 <a:solidFill>
-                  <a:srgbClr val="E2E8F0"/>
+                  <a:srgbClr val="CBD5E1"/>
                 </a:solidFill>
               </a:defRPr>
             </a:pPr>
@@ -3899,11 +3899,11 @@
             <a:avLst/>
           </a:prstGeom>
           <a:solidFill>
-            <a:srgbClr val="1E232C"/>
+            <a:srgbClr val="2E2B2B"/>
           </a:solidFill>
           <a:ln w="15240">
             <a:solidFill>
-              <a:srgbClr val="3C4858"/>
+              <a:srgbClr val="5C5656"/>
             </a:solidFill>
           </a:ln>
         </p:spPr>
@@ -3944,7 +3944,7 @@
             <a:avLst/>
           </a:prstGeom>
           <a:solidFill>
-            <a:srgbClr val="FFFFFF"/>
+            <a:srgbClr val="FFF212"/>
           </a:solidFill>
           <a:ln>
             <a:noFill/>
@@ -3997,7 +3997,7 @@
             <a:pPr>
               <a:defRPr sz="1600" b="1">
                 <a:solidFill>
-                  <a:srgbClr val="FFFFFF"/>
+                  <a:srgbClr val="FFF212"/>
                 </a:solidFill>
               </a:defRPr>
             </a:pPr>
@@ -4027,7 +4027,7 @@
               </a:spcBef>
               <a:defRPr sz="1000">
                 <a:solidFill>
-                  <a:srgbClr val="F59E0B"/>
+                  <a:srgbClr val="F1F5F9"/>
                 </a:solidFill>
               </a:defRPr>
             </a:pPr>
@@ -4046,7 +4046,7 @@
               </a:spcBef>
               <a:defRPr sz="1050">
                 <a:solidFill>
-                  <a:srgbClr val="E2E8F0"/>
+                  <a:srgbClr val="CBD5E1"/>
                 </a:solidFill>
               </a:defRPr>
             </a:pPr>
@@ -4075,11 +4075,11 @@
             <a:avLst/>
           </a:prstGeom>
           <a:solidFill>
-            <a:srgbClr val="1E232C"/>
+            <a:srgbClr val="2E2B2B"/>
           </a:solidFill>
           <a:ln w="15240">
             <a:solidFill>
-              <a:srgbClr val="3C4858"/>
+              <a:srgbClr val="5C5656"/>
             </a:solidFill>
           </a:ln>
         </p:spPr>
@@ -4120,7 +4120,7 @@
             <a:avLst/>
           </a:prstGeom>
           <a:solidFill>
-            <a:srgbClr val="F59E0B"/>
+            <a:srgbClr val="FFF212"/>
           </a:solidFill>
           <a:ln>
             <a:noFill/>
@@ -4173,7 +4173,7 @@
             <a:pPr>
               <a:defRPr sz="1600" b="1">
                 <a:solidFill>
-                  <a:srgbClr val="F59E0B"/>
+                  <a:srgbClr val="FFF212"/>
                 </a:solidFill>
               </a:defRPr>
             </a:pPr>
@@ -4203,7 +4203,7 @@
               </a:spcBef>
               <a:defRPr sz="1000">
                 <a:solidFill>
-                  <a:srgbClr val="F59E0B"/>
+                  <a:srgbClr val="F1F5F9"/>
                 </a:solidFill>
               </a:defRPr>
             </a:pPr>
@@ -4222,7 +4222,7 @@
               </a:spcBef>
               <a:defRPr sz="1050">
                 <a:solidFill>
-                  <a:srgbClr val="E2E8F0"/>
+                  <a:srgbClr val="CBD5E1"/>
                 </a:solidFill>
               </a:defRPr>
             </a:pPr>
@@ -4251,11 +4251,11 @@
             <a:avLst/>
           </a:prstGeom>
           <a:solidFill>
-            <a:srgbClr val="1E232C"/>
+            <a:srgbClr val="2E2B2B"/>
           </a:solidFill>
           <a:ln w="15240">
             <a:solidFill>
-              <a:srgbClr val="3C4858"/>
+              <a:srgbClr val="5C5656"/>
             </a:solidFill>
           </a:ln>
         </p:spPr>
@@ -4296,7 +4296,7 @@
             <a:avLst/>
           </a:prstGeom>
           <a:solidFill>
-            <a:srgbClr val="94A3B8"/>
+            <a:srgbClr val="FFF212"/>
           </a:solidFill>
           <a:ln>
             <a:noFill/>
@@ -4349,7 +4349,7 @@
             <a:pPr>
               <a:defRPr sz="1600" b="1">
                 <a:solidFill>
-                  <a:srgbClr val="94A3B8"/>
+                  <a:srgbClr val="FFF212"/>
                 </a:solidFill>
               </a:defRPr>
             </a:pPr>
@@ -4379,7 +4379,7 @@
               </a:spcBef>
               <a:defRPr sz="1000">
                 <a:solidFill>
-                  <a:srgbClr val="F59E0B"/>
+                  <a:srgbClr val="F1F5F9"/>
                 </a:solidFill>
               </a:defRPr>
             </a:pPr>
@@ -4398,7 +4398,7 @@
               </a:spcBef>
               <a:defRPr sz="1050">
                 <a:solidFill>
-                  <a:srgbClr val="E2E8F0"/>
+                  <a:srgbClr val="CBD5E1"/>
                 </a:solidFill>
               </a:defRPr>
             </a:pPr>
@@ -4445,7 +4445,7 @@
             <a:avLst/>
           </a:prstGeom>
           <a:solidFill>
-            <a:srgbClr val="14171D"/>
+            <a:srgbClr val="383535"/>
           </a:solidFill>
           <a:ln>
             <a:noFill/>
@@ -4482,13 +4482,13 @@
         <p:spPr>
           <a:xfrm>
             <a:off x="0" y="0"/>
-            <a:ext cx="12191695" cy="82296"/>
+            <a:ext cx="12191695" cy="91440"/>
           </a:xfrm>
           <a:prstGeom prst="rect">
             <a:avLst/>
           </a:prstGeom>
           <a:solidFill>
-            <a:srgbClr val="F59E0B"/>
+            <a:srgbClr val="FFF212"/>
           </a:solidFill>
           <a:ln>
             <a:noFill/>
@@ -4541,7 +4541,7 @@
             <a:pPr>
               <a:defRPr sz="950" b="1">
                 <a:solidFill>
-                  <a:srgbClr val="F59E0B"/>
+                  <a:srgbClr val="FFF212"/>
                 </a:solidFill>
                 <a:latin typeface="Arial"/>
               </a:defRPr>
@@ -4607,11 +4607,11 @@
             <a:avLst/>
           </a:prstGeom>
           <a:solidFill>
-            <a:srgbClr val="1E232C"/>
+            <a:srgbClr val="2E2B2B"/>
           </a:solidFill>
           <a:ln w="15240">
             <a:solidFill>
-              <a:srgbClr val="3C4858"/>
+              <a:srgbClr val="5C5656"/>
             </a:solidFill>
           </a:ln>
         </p:spPr>
@@ -4662,7 +4662,7 @@
             <a:pPr>
               <a:defRPr sz="1600" b="1">
                 <a:solidFill>
-                  <a:srgbClr val="F59E0B"/>
+                  <a:srgbClr val="FFF212"/>
                 </a:solidFill>
               </a:defRPr>
             </a:pPr>
@@ -4677,7 +4677,7 @@
               </a:spcBef>
               <a:defRPr sz="1200">
                 <a:solidFill>
-                  <a:srgbClr val="E2E8F0"/>
+                  <a:srgbClr val="F1F5F9"/>
                 </a:solidFill>
               </a:defRPr>
             </a:pPr>
@@ -4702,11 +4702,11 @@
             <a:avLst/>
           </a:prstGeom>
           <a:solidFill>
-            <a:srgbClr val="1E232C"/>
+            <a:srgbClr val="2E2B2B"/>
           </a:solidFill>
           <a:ln w="15240">
             <a:solidFill>
-              <a:srgbClr val="3C4858"/>
+              <a:srgbClr val="5C5656"/>
             </a:solidFill>
           </a:ln>
         </p:spPr>
@@ -4757,7 +4757,7 @@
             <a:pPr>
               <a:defRPr sz="1600" b="1">
                 <a:solidFill>
-                  <a:srgbClr val="F59E0B"/>
+                  <a:srgbClr val="FFF212"/>
                 </a:solidFill>
               </a:defRPr>
             </a:pPr>
@@ -4772,7 +4772,7 @@
               </a:spcBef>
               <a:defRPr sz="1200">
                 <a:solidFill>
-                  <a:srgbClr val="E2E8F0"/>
+                  <a:srgbClr val="F1F5F9"/>
                 </a:solidFill>
               </a:defRPr>
             </a:pPr>
@@ -4797,11 +4797,11 @@
             <a:avLst/>
           </a:prstGeom>
           <a:solidFill>
-            <a:srgbClr val="1E232C"/>
+            <a:srgbClr val="2E2B2B"/>
           </a:solidFill>
           <a:ln w="15240">
             <a:solidFill>
-              <a:srgbClr val="3C4858"/>
+              <a:srgbClr val="5C5656"/>
             </a:solidFill>
           </a:ln>
         </p:spPr>
@@ -4852,7 +4852,7 @@
             <a:pPr>
               <a:defRPr sz="1600" b="1">
                 <a:solidFill>
-                  <a:srgbClr val="F59E0B"/>
+                  <a:srgbClr val="FFF212"/>
                 </a:solidFill>
               </a:defRPr>
             </a:pPr>
@@ -4867,7 +4867,7 @@
               </a:spcBef>
               <a:defRPr sz="1200">
                 <a:solidFill>
-                  <a:srgbClr val="E2E8F0"/>
+                  <a:srgbClr val="F1F5F9"/>
                 </a:solidFill>
               </a:defRPr>
             </a:pPr>
@@ -4892,11 +4892,11 @@
             <a:avLst/>
           </a:prstGeom>
           <a:solidFill>
-            <a:srgbClr val="1E232C"/>
+            <a:srgbClr val="2E2B2B"/>
           </a:solidFill>
           <a:ln w="15240">
             <a:solidFill>
-              <a:srgbClr val="3C4858"/>
+              <a:srgbClr val="5C5656"/>
             </a:solidFill>
           </a:ln>
         </p:spPr>
@@ -4947,7 +4947,7 @@
             <a:pPr>
               <a:defRPr sz="1600" b="1">
                 <a:solidFill>
-                  <a:srgbClr val="F59E0B"/>
+                  <a:srgbClr val="FFF212"/>
                 </a:solidFill>
               </a:defRPr>
             </a:pPr>
@@ -4962,7 +4962,7 @@
               </a:spcBef>
               <a:defRPr sz="1200">
                 <a:solidFill>
-                  <a:srgbClr val="E2E8F0"/>
+                  <a:srgbClr val="F1F5F9"/>
                 </a:solidFill>
               </a:defRPr>
             </a:pPr>
@@ -5005,7 +5005,7 @@
             <a:avLst/>
           </a:prstGeom>
           <a:solidFill>
-            <a:srgbClr val="14171D"/>
+            <a:srgbClr val="383535"/>
           </a:solidFill>
           <a:ln>
             <a:noFill/>
@@ -5042,13 +5042,13 @@
         <p:spPr>
           <a:xfrm>
             <a:off x="0" y="0"/>
-            <a:ext cx="12191695" cy="82296"/>
+            <a:ext cx="12191695" cy="91440"/>
           </a:xfrm>
           <a:prstGeom prst="rect">
             <a:avLst/>
           </a:prstGeom>
           <a:solidFill>
-            <a:srgbClr val="F59E0B"/>
+            <a:srgbClr val="FFF212"/>
           </a:solidFill>
           <a:ln>
             <a:noFill/>
@@ -5101,7 +5101,7 @@
             <a:pPr>
               <a:defRPr sz="950" b="1">
                 <a:solidFill>
-                  <a:srgbClr val="F59E0B"/>
+                  <a:srgbClr val="FFF212"/>
                 </a:solidFill>
                 <a:latin typeface="Arial"/>
               </a:defRPr>
@@ -5167,11 +5167,11 @@
             <a:avLst/>
           </a:prstGeom>
           <a:solidFill>
-            <a:srgbClr val="1E232C"/>
+            <a:srgbClr val="2E2B2B"/>
           </a:solidFill>
           <a:ln w="15240">
             <a:solidFill>
-              <a:srgbClr val="3C4858"/>
+              <a:srgbClr val="5C5656"/>
             </a:solidFill>
           </a:ln>
         </p:spPr>
@@ -5246,7 +5246,7 @@
             <a:pPr>
               <a:defRPr sz="1400" b="1">
                 <a:solidFill>
-                  <a:srgbClr val="F59E0B"/>
+                  <a:srgbClr val="FFF212"/>
                 </a:solidFill>
               </a:defRPr>
             </a:pPr>
@@ -5261,7 +5261,7 @@
               </a:spcBef>
               <a:defRPr sz="1050">
                 <a:solidFill>
-                  <a:srgbClr val="E2E8F0"/>
+                  <a:srgbClr val="F1F5F9"/>
                 </a:solidFill>
               </a:defRPr>
             </a:pPr>
@@ -5286,11 +5286,11 @@
             <a:avLst/>
           </a:prstGeom>
           <a:solidFill>
-            <a:srgbClr val="1E232C"/>
+            <a:srgbClr val="2E2B2B"/>
           </a:solidFill>
           <a:ln w="15240">
             <a:solidFill>
-              <a:srgbClr val="3C4858"/>
+              <a:srgbClr val="5C5656"/>
             </a:solidFill>
           </a:ln>
         </p:spPr>
@@ -5365,7 +5365,7 @@
             <a:pPr>
               <a:defRPr sz="1400" b="1">
                 <a:solidFill>
-                  <a:srgbClr val="F59E0B"/>
+                  <a:srgbClr val="FFF212"/>
                 </a:solidFill>
               </a:defRPr>
             </a:pPr>
@@ -5380,7 +5380,7 @@
               </a:spcBef>
               <a:defRPr sz="1050">
                 <a:solidFill>
-                  <a:srgbClr val="E2E8F0"/>
+                  <a:srgbClr val="F1F5F9"/>
                 </a:solidFill>
               </a:defRPr>
             </a:pPr>
@@ -5405,11 +5405,11 @@
             <a:avLst/>
           </a:prstGeom>
           <a:solidFill>
-            <a:srgbClr val="1E232C"/>
+            <a:srgbClr val="2E2B2B"/>
           </a:solidFill>
           <a:ln w="15240">
             <a:solidFill>
-              <a:srgbClr val="3C4858"/>
+              <a:srgbClr val="5C5656"/>
             </a:solidFill>
           </a:ln>
         </p:spPr>
@@ -5484,7 +5484,7 @@
             <a:pPr>
               <a:defRPr sz="1400" b="1">
                 <a:solidFill>
-                  <a:srgbClr val="F59E0B"/>
+                  <a:srgbClr val="FFF212"/>
                 </a:solidFill>
               </a:defRPr>
             </a:pPr>
@@ -5499,7 +5499,7 @@
               </a:spcBef>
               <a:defRPr sz="1050">
                 <a:solidFill>
-                  <a:srgbClr val="E2E8F0"/>
+                  <a:srgbClr val="F1F5F9"/>
                 </a:solidFill>
               </a:defRPr>
             </a:pPr>
@@ -5524,11 +5524,11 @@
             <a:avLst/>
           </a:prstGeom>
           <a:solidFill>
-            <a:srgbClr val="1E232C"/>
+            <a:srgbClr val="2E2B2B"/>
           </a:solidFill>
           <a:ln w="15240">
             <a:solidFill>
-              <a:srgbClr val="3C4858"/>
+              <a:srgbClr val="5C5656"/>
             </a:solidFill>
           </a:ln>
         </p:spPr>
@@ -5603,7 +5603,7 @@
             <a:pPr>
               <a:defRPr sz="1400" b="1">
                 <a:solidFill>
-                  <a:srgbClr val="F59E0B"/>
+                  <a:srgbClr val="FFF212"/>
                 </a:solidFill>
               </a:defRPr>
             </a:pPr>
@@ -5618,7 +5618,7 @@
               </a:spcBef>
               <a:defRPr sz="1050">
                 <a:solidFill>
-                  <a:srgbClr val="E2E8F0"/>
+                  <a:srgbClr val="F1F5F9"/>
                 </a:solidFill>
               </a:defRPr>
             </a:pPr>
@@ -5661,7 +5661,7 @@
             <a:avLst/>
           </a:prstGeom>
           <a:solidFill>
-            <a:srgbClr val="14171D"/>
+            <a:srgbClr val="383535"/>
           </a:solidFill>
           <a:ln>
             <a:noFill/>
@@ -5698,13 +5698,13 @@
         <p:spPr>
           <a:xfrm>
             <a:off x="0" y="0"/>
-            <a:ext cx="12191695" cy="82296"/>
+            <a:ext cx="12191695" cy="91440"/>
           </a:xfrm>
           <a:prstGeom prst="rect">
             <a:avLst/>
           </a:prstGeom>
           <a:solidFill>
-            <a:srgbClr val="F59E0B"/>
+            <a:srgbClr val="FFF212"/>
           </a:solidFill>
           <a:ln>
             <a:noFill/>
@@ -5757,7 +5757,7 @@
             <a:pPr>
               <a:defRPr sz="950" b="1">
                 <a:solidFill>
-                  <a:srgbClr val="F59E0B"/>
+                  <a:srgbClr val="FFF212"/>
                 </a:solidFill>
                 <a:latin typeface="Arial"/>
               </a:defRPr>
@@ -5823,11 +5823,11 @@
             <a:avLst/>
           </a:prstGeom>
           <a:solidFill>
-            <a:srgbClr val="1E232C"/>
+            <a:srgbClr val="2E2B2B"/>
           </a:solidFill>
           <a:ln w="15240">
             <a:solidFill>
-              <a:srgbClr val="3C4858"/>
+              <a:srgbClr val="FFF212"/>
             </a:solidFill>
           </a:ln>
         </p:spPr>
@@ -5878,7 +5878,7 @@
             <a:pPr>
               <a:defRPr sz="1600" b="1">
                 <a:solidFill>
-                  <a:srgbClr val="F59E0B"/>
+                  <a:srgbClr val="FFF212"/>
                 </a:solidFill>
               </a:defRPr>
             </a:pPr>
@@ -5893,7 +5893,7 @@
               </a:spcBef>
               <a:defRPr sz="1100">
                 <a:solidFill>
-                  <a:srgbClr val="E2E8F0"/>
+                  <a:srgbClr val="F1F5F9"/>
                 </a:solidFill>
               </a:defRPr>
             </a:pPr>
@@ -5936,11 +5936,11 @@
             <a:avLst/>
           </a:prstGeom>
           <a:solidFill>
-            <a:srgbClr val="1E232C"/>
+            <a:srgbClr val="474444"/>
           </a:solidFill>
           <a:ln w="15240">
             <a:solidFill>
-              <a:srgbClr val="3C4858"/>
+              <a:srgbClr val="5C5656"/>
             </a:solidFill>
           </a:ln>
         </p:spPr>
@@ -6006,7 +6006,7 @@
               </a:spcBef>
               <a:defRPr sz="1100">
                 <a:solidFill>
-                  <a:srgbClr val="E2E8F0"/>
+                  <a:srgbClr val="F1F5F9"/>
                 </a:solidFill>
               </a:defRPr>
             </a:pPr>
@@ -6041,11 +6041,11 @@
             <a:avLst/>
           </a:prstGeom>
           <a:solidFill>
-            <a:srgbClr val="1E232C"/>
+            <a:srgbClr val="2E2B2B"/>
           </a:solidFill>
           <a:ln w="15240">
             <a:solidFill>
-              <a:srgbClr val="3C4858"/>
+              <a:srgbClr val="FFF212"/>
             </a:solidFill>
           </a:ln>
         </p:spPr>
@@ -6096,7 +6096,7 @@
             <a:pPr>
               <a:defRPr sz="1600" b="1">
                 <a:solidFill>
-                  <a:srgbClr val="F59E0B"/>
+                  <a:srgbClr val="FFF212"/>
                 </a:solidFill>
               </a:defRPr>
             </a:pPr>
@@ -6111,7 +6111,7 @@
               </a:spcBef>
               <a:defRPr sz="1100">
                 <a:solidFill>
-                  <a:srgbClr val="E2E8F0"/>
+                  <a:srgbClr val="F1F5F9"/>
                 </a:solidFill>
               </a:defRPr>
             </a:pPr>
@@ -6121,17 +6121,29 @@
             <a:br/>
             <a:br/>
             <a:r>
-              <a:t>🟢 Appwrite OK: Todos os laudos já estão salvos e sincronizados na nuvem.</a:t>
-            </a:r>
-            <a:br/>
-            <a:br/>
-            <a:r>
-              <a:t>🟡 X Pendente(s): Há laudos na fila aguardando término de transmissão.</a:t>
-            </a:r>
-            <a:br/>
-            <a:br/>
-            <a:r>
-              <a:t>🔴 Offline Pátio: Celular sem sinal; dados protegidos na memória local.</a:t>
+              <a:t>• Appwrite OK (Verde):</a:t>
+            </a:r>
+            <a:br/>
+            <a:r>
+              <a:t>  Todos os laudos já estão salvos e sincronizados na nuvem.</a:t>
+            </a:r>
+            <a:br/>
+            <a:br/>
+            <a:r>
+              <a:t>• X Pendente(s) (Amarelo):</a:t>
+            </a:r>
+            <a:br/>
+            <a:r>
+              <a:t>  Há laudos na fila aguardando término de transmissão.</a:t>
+            </a:r>
+            <a:br/>
+            <a:br/>
+            <a:r>
+              <a:t>• Offline Pátio (Vermelho):</a:t>
+            </a:r>
+            <a:br/>
+            <a:r>
+              <a:t>  Celular sem sinal; dados protegidos na memória local.</a:t>
             </a:r>
           </a:p>
         </p:txBody>
@@ -6169,7 +6181,7 @@
             <a:avLst/>
           </a:prstGeom>
           <a:solidFill>
-            <a:srgbClr val="14171D"/>
+            <a:srgbClr val="383535"/>
           </a:solidFill>
           <a:ln>
             <a:noFill/>
@@ -6206,13 +6218,13 @@
         <p:spPr>
           <a:xfrm>
             <a:off x="0" y="0"/>
-            <a:ext cx="12191695" cy="82296"/>
+            <a:ext cx="12191695" cy="91440"/>
           </a:xfrm>
           <a:prstGeom prst="rect">
             <a:avLst/>
           </a:prstGeom>
           <a:solidFill>
-            <a:srgbClr val="F59E0B"/>
+            <a:srgbClr val="FFF212"/>
           </a:solidFill>
           <a:ln>
             <a:noFill/>
@@ -6265,7 +6277,7 @@
             <a:pPr>
               <a:defRPr sz="950" b="1">
                 <a:solidFill>
-                  <a:srgbClr val="F59E0B"/>
+                  <a:srgbClr val="FFF212"/>
                 </a:solidFill>
                 <a:latin typeface="Arial"/>
               </a:defRPr>
@@ -6331,11 +6343,11 @@
             <a:avLst/>
           </a:prstGeom>
           <a:solidFill>
-            <a:srgbClr val="1E232C"/>
+            <a:srgbClr val="2E2B2B"/>
           </a:solidFill>
           <a:ln w="15240">
             <a:solidFill>
-              <a:srgbClr val="3C4858"/>
+              <a:srgbClr val="5C5656"/>
             </a:solidFill>
           </a:ln>
         </p:spPr>
@@ -6386,7 +6398,7 @@
             <a:pPr>
               <a:defRPr sz="1800" b="1">
                 <a:solidFill>
-                  <a:srgbClr val="F59E0B"/>
+                  <a:srgbClr val="FFF212"/>
                 </a:solidFill>
               </a:defRPr>
             </a:pPr>
@@ -6401,7 +6413,7 @@
               </a:spcBef>
               <a:defRPr sz="1150">
                 <a:solidFill>
-                  <a:srgbClr val="E2E8F0"/>
+                  <a:srgbClr val="F1F5F9"/>
                 </a:solidFill>
               </a:defRPr>
             </a:pPr>
@@ -6448,11 +6460,11 @@
             <a:avLst/>
           </a:prstGeom>
           <a:solidFill>
-            <a:srgbClr val="262C38"/>
+            <a:srgbClr val="474444"/>
           </a:solidFill>
           <a:ln w="15240">
             <a:solidFill>
-              <a:srgbClr val="F59E0B"/>
+              <a:srgbClr val="FFF212"/>
             </a:solidFill>
           </a:ln>
         </p:spPr>
@@ -6518,7 +6530,7 @@
               </a:spcBef>
               <a:defRPr sz="1300" b="1">
                 <a:solidFill>
-                  <a:srgbClr val="10B981"/>
+                  <a:srgbClr val="FFF212"/>
                 </a:solidFill>
               </a:defRPr>
             </a:pPr>
@@ -6533,7 +6545,7 @@
               </a:spcBef>
               <a:defRPr sz="1150">
                 <a:solidFill>
-                  <a:srgbClr val="E2E8F0"/>
+                  <a:srgbClr val="F1F5F9"/>
                 </a:solidFill>
               </a:defRPr>
             </a:pPr>
@@ -6590,7 +6602,7 @@
             <a:avLst/>
           </a:prstGeom>
           <a:solidFill>
-            <a:srgbClr val="14171D"/>
+            <a:srgbClr val="383535"/>
           </a:solidFill>
           <a:ln>
             <a:noFill/>
@@ -6627,13 +6639,13 @@
         <p:spPr>
           <a:xfrm>
             <a:off x="0" y="0"/>
-            <a:ext cx="12191695" cy="82296"/>
+            <a:ext cx="12191695" cy="91440"/>
           </a:xfrm>
           <a:prstGeom prst="rect">
             <a:avLst/>
           </a:prstGeom>
           <a:solidFill>
-            <a:srgbClr val="F59E0B"/>
+            <a:srgbClr val="FFF212"/>
           </a:solidFill>
           <a:ln>
             <a:noFill/>
@@ -6686,7 +6698,7 @@
             <a:pPr>
               <a:defRPr sz="950" b="1">
                 <a:solidFill>
-                  <a:srgbClr val="F59E0B"/>
+                  <a:srgbClr val="FFF212"/>
                 </a:solidFill>
                 <a:latin typeface="Arial"/>
               </a:defRPr>
@@ -6752,11 +6764,11 @@
             <a:avLst/>
           </a:prstGeom>
           <a:solidFill>
-            <a:srgbClr val="1E232C"/>
+            <a:srgbClr val="2E2B2B"/>
           </a:solidFill>
           <a:ln w="15240">
             <a:solidFill>
-              <a:srgbClr val="EF4444"/>
+              <a:srgbClr val="FFF212"/>
             </a:solidFill>
           </a:ln>
         </p:spPr>
@@ -6807,7 +6819,7 @@
             <a:pPr>
               <a:defRPr sz="1700" b="1">
                 <a:solidFill>
-                  <a:srgbClr val="EF4444"/>
+                  <a:srgbClr val="FFFFFF"/>
                 </a:solidFill>
               </a:defRPr>
             </a:pPr>
@@ -6822,7 +6834,7 @@
               </a:spcBef>
               <a:defRPr sz="1100">
                 <a:solidFill>
-                  <a:srgbClr val="94A3B8"/>
+                  <a:srgbClr val="CBD5E1"/>
                 </a:solidFill>
               </a:defRPr>
             </a:pPr>
@@ -6837,7 +6849,7 @@
               </a:spcBef>
               <a:defRPr sz="2000" b="1">
                 <a:solidFill>
-                  <a:srgbClr val="F59E0B"/>
+                  <a:srgbClr val="FFF212"/>
                 </a:solidFill>
               </a:defRPr>
             </a:pPr>
@@ -6852,7 +6864,7 @@
               </a:spcBef>
               <a:defRPr sz="1150">
                 <a:solidFill>
-                  <a:srgbClr val="E2E8F0"/>
+                  <a:srgbClr val="F1F5F9"/>
                 </a:solidFill>
               </a:defRPr>
             </a:pPr>
@@ -6889,11 +6901,11 @@
             <a:avLst/>
           </a:prstGeom>
           <a:solidFill>
-            <a:srgbClr val="1E232C"/>
+            <a:srgbClr val="474444"/>
           </a:solidFill>
           <a:ln w="15240">
             <a:solidFill>
-              <a:srgbClr val="10B981"/>
+              <a:srgbClr val="5C5656"/>
             </a:solidFill>
           </a:ln>
         </p:spPr>
@@ -6944,7 +6956,7 @@
             <a:pPr>
               <a:defRPr sz="1700" b="1">
                 <a:solidFill>
-                  <a:srgbClr val="10B981"/>
+                  <a:srgbClr val="FFF212"/>
                 </a:solidFill>
               </a:defRPr>
             </a:pPr>
@@ -6959,7 +6971,7 @@
               </a:spcBef>
               <a:defRPr sz="1100">
                 <a:solidFill>
-                  <a:srgbClr val="94A3B8"/>
+                  <a:srgbClr val="CBD5E1"/>
                 </a:solidFill>
               </a:defRPr>
             </a:pPr>
@@ -6974,7 +6986,7 @@
               </a:spcBef>
               <a:defRPr sz="2000" b="1">
                 <a:solidFill>
-                  <a:srgbClr val="10B981"/>
+                  <a:srgbClr val="FFFFFF"/>
                 </a:solidFill>
               </a:defRPr>
             </a:pPr>
@@ -6989,7 +7001,7 @@
               </a:spcBef>
               <a:defRPr sz="1150">
                 <a:solidFill>
-                  <a:srgbClr val="E2E8F0"/>
+                  <a:srgbClr val="F1F5F9"/>
                 </a:solidFill>
               </a:defRPr>
             </a:pPr>
@@ -7006,7 +7018,7 @@
             </a:r>
             <a:br/>
             <a:r>
-              <a:t>• Laudo Liberado: Emissão do laudo com selo verde, QR Code e Hash SHA-256.</a:t>
+              <a:t>• Laudo Liberado: Emissão do laudo com selo de liberação, QR Code e Hash SHA-256.</a:t>
             </a:r>
           </a:p>
         </p:txBody>
@@ -7044,7 +7056,7 @@
             <a:avLst/>
           </a:prstGeom>
           <a:solidFill>
-            <a:srgbClr val="14171D"/>
+            <a:srgbClr val="383535"/>
           </a:solidFill>
           <a:ln>
             <a:noFill/>
@@ -7081,13 +7093,13 @@
         <p:spPr>
           <a:xfrm>
             <a:off x="0" y="0"/>
-            <a:ext cx="12191695" cy="82296"/>
+            <a:ext cx="12191695" cy="91440"/>
           </a:xfrm>
           <a:prstGeom prst="rect">
             <a:avLst/>
           </a:prstGeom>
           <a:solidFill>
-            <a:srgbClr val="F59E0B"/>
+            <a:srgbClr val="FFF212"/>
           </a:solidFill>
           <a:ln>
             <a:noFill/>
@@ -7140,7 +7152,7 @@
             <a:pPr>
               <a:defRPr sz="950" b="1">
                 <a:solidFill>
-                  <a:srgbClr val="F59E0B"/>
+                  <a:srgbClr val="FFF212"/>
                 </a:solidFill>
                 <a:latin typeface="Arial"/>
               </a:defRPr>
@@ -7230,11 +7242,11 @@
             <a:avLst/>
           </a:prstGeom>
           <a:solidFill>
-            <a:srgbClr val="1E232C"/>
+            <a:srgbClr val="2E2B2B"/>
           </a:solidFill>
           <a:ln w="15240">
             <a:solidFill>
-              <a:srgbClr val="3C4858"/>
+              <a:srgbClr val="5C5656"/>
             </a:solidFill>
           </a:ln>
         </p:spPr>
@@ -7285,7 +7297,7 @@
             <a:pPr>
               <a:defRPr sz="1700" b="1">
                 <a:solidFill>
-                  <a:srgbClr val="F59E0B"/>
+                  <a:srgbClr val="FFF212"/>
                 </a:solidFill>
               </a:defRPr>
             </a:pPr>
@@ -7300,7 +7312,7 @@
               </a:spcBef>
               <a:defRPr sz="1150">
                 <a:solidFill>
-                  <a:srgbClr val="E2E8F0"/>
+                  <a:srgbClr val="F1F5F9"/>
                 </a:solidFill>
               </a:defRPr>
             </a:pPr>
@@ -7378,7 +7390,7 @@
             <a:avLst/>
           </a:prstGeom>
           <a:solidFill>
-            <a:srgbClr val="14171D"/>
+            <a:srgbClr val="383535"/>
           </a:solidFill>
           <a:ln>
             <a:noFill/>
@@ -7415,13 +7427,13 @@
         <p:spPr>
           <a:xfrm>
             <a:off x="0" y="0"/>
-            <a:ext cx="12191695" cy="82296"/>
+            <a:ext cx="12191695" cy="91440"/>
           </a:xfrm>
           <a:prstGeom prst="rect">
             <a:avLst/>
           </a:prstGeom>
           <a:solidFill>
-            <a:srgbClr val="F59E0B"/>
+            <a:srgbClr val="FFF212"/>
           </a:solidFill>
           <a:ln>
             <a:noFill/>
@@ -7474,7 +7486,7 @@
             <a:pPr>
               <a:defRPr sz="950" b="1">
                 <a:solidFill>
-                  <a:srgbClr val="F59E0B"/>
+                  <a:srgbClr val="FFF212"/>
                 </a:solidFill>
                 <a:latin typeface="Arial"/>
               </a:defRPr>
@@ -7564,11 +7576,11 @@
             <a:avLst/>
           </a:prstGeom>
           <a:solidFill>
-            <a:srgbClr val="1E232C"/>
+            <a:srgbClr val="2E2B2B"/>
           </a:solidFill>
           <a:ln w="15240">
             <a:solidFill>
-              <a:srgbClr val="3C4858"/>
+              <a:srgbClr val="FFF212"/>
             </a:solidFill>
           </a:ln>
         </p:spPr>
@@ -7619,7 +7631,7 @@
             <a:pPr>
               <a:defRPr sz="1700" b="1">
                 <a:solidFill>
-                  <a:srgbClr val="F59E0B"/>
+                  <a:srgbClr val="FFF212"/>
                 </a:solidFill>
               </a:defRPr>
             </a:pPr>
@@ -7634,7 +7646,7 @@
               </a:spcBef>
               <a:defRPr sz="1150">
                 <a:solidFill>
-                  <a:srgbClr val="E2E8F0"/>
+                  <a:srgbClr val="F1F5F9"/>
                 </a:solidFill>
               </a:defRPr>
             </a:pPr>
@@ -7708,7 +7720,7 @@
             <a:avLst/>
           </a:prstGeom>
           <a:solidFill>
-            <a:srgbClr val="14171D"/>
+            <a:srgbClr val="383535"/>
           </a:solidFill>
           <a:ln>
             <a:noFill/>
@@ -7745,13 +7757,13 @@
         <p:spPr>
           <a:xfrm>
             <a:off x="0" y="0"/>
-            <a:ext cx="12191695" cy="82296"/>
+            <a:ext cx="12191695" cy="91440"/>
           </a:xfrm>
           <a:prstGeom prst="rect">
             <a:avLst/>
           </a:prstGeom>
           <a:solidFill>
-            <a:srgbClr val="F59E0B"/>
+            <a:srgbClr val="FFF212"/>
           </a:solidFill>
           <a:ln>
             <a:noFill/>
@@ -7804,7 +7816,7 @@
             <a:pPr>
               <a:defRPr sz="950" b="1">
                 <a:solidFill>
-                  <a:srgbClr val="F59E0B"/>
+                  <a:srgbClr val="FFF212"/>
                 </a:solidFill>
                 <a:latin typeface="Arial"/>
               </a:defRPr>
@@ -7894,11 +7906,11 @@
             <a:avLst/>
           </a:prstGeom>
           <a:solidFill>
-            <a:srgbClr val="1E232C"/>
+            <a:srgbClr val="2E2B2B"/>
           </a:solidFill>
           <a:ln w="15240">
             <a:solidFill>
-              <a:srgbClr val="3C4858"/>
+              <a:srgbClr val="5C5656"/>
             </a:solidFill>
           </a:ln>
         </p:spPr>
@@ -7949,7 +7961,7 @@
             <a:pPr>
               <a:defRPr sz="1700" b="1">
                 <a:solidFill>
-                  <a:srgbClr val="F59E0B"/>
+                  <a:srgbClr val="FFF212"/>
                 </a:solidFill>
               </a:defRPr>
             </a:pPr>
@@ -7964,7 +7976,7 @@
               </a:spcBef>
               <a:defRPr sz="1150">
                 <a:solidFill>
-                  <a:srgbClr val="E2E8F0"/>
+                  <a:srgbClr val="F1F5F9"/>
                 </a:solidFill>
               </a:defRPr>
             </a:pPr>
@@ -8042,7 +8054,7 @@
             <a:avLst/>
           </a:prstGeom>
           <a:solidFill>
-            <a:srgbClr val="14171D"/>
+            <a:srgbClr val="383535"/>
           </a:solidFill>
           <a:ln>
             <a:noFill/>
@@ -8079,13 +8091,13 @@
         <p:spPr>
           <a:xfrm>
             <a:off x="0" y="0"/>
-            <a:ext cx="12191695" cy="82296"/>
+            <a:ext cx="12191695" cy="91440"/>
           </a:xfrm>
           <a:prstGeom prst="rect">
             <a:avLst/>
           </a:prstGeom>
           <a:solidFill>
-            <a:srgbClr val="F59E0B"/>
+            <a:srgbClr val="FFF212"/>
           </a:solidFill>
           <a:ln>
             <a:noFill/>
@@ -8138,7 +8150,7 @@
             <a:pPr>
               <a:defRPr sz="950" b="1">
                 <a:solidFill>
-                  <a:srgbClr val="F59E0B"/>
+                  <a:srgbClr val="FFF212"/>
                 </a:solidFill>
                 <a:latin typeface="Arial"/>
               </a:defRPr>
@@ -8228,11 +8240,11 @@
             <a:avLst/>
           </a:prstGeom>
           <a:solidFill>
-            <a:srgbClr val="1E232C"/>
+            <a:srgbClr val="474444"/>
           </a:solidFill>
           <a:ln w="15240">
             <a:solidFill>
-              <a:srgbClr val="3C4858"/>
+              <a:srgbClr val="FFF212"/>
             </a:solidFill>
           </a:ln>
         </p:spPr>
@@ -8283,7 +8295,7 @@
             <a:pPr>
               <a:defRPr sz="1700" b="1">
                 <a:solidFill>
-                  <a:srgbClr val="F59E0B"/>
+                  <a:srgbClr val="FFFFFF"/>
                 </a:solidFill>
               </a:defRPr>
             </a:pPr>
@@ -8298,7 +8310,7 @@
               </a:spcBef>
               <a:defRPr sz="1150">
                 <a:solidFill>
-                  <a:srgbClr val="E2E8F0"/>
+                  <a:srgbClr val="F1F5F9"/>
                 </a:solidFill>
               </a:defRPr>
             </a:pPr>

</xml_diff>